<commit_message>
Arreglo informe y presentación
</commit_message>
<xml_diff>
--- a/docs/EP1_Spotify_Presentacion_1.pptx
+++ b/docs/EP1_Spotify_Presentacion_1.pptx
@@ -20706,7 +20706,7 @@
                 <a:cs typeface="Calibri"/>
                 <a:sym typeface="Calibri"/>
               </a:rPr>
-              <a:t>album_name/artists correlacionan 0,72/0,71 con popularity; se excluyeron a propósito</a:t>
+              <a:t>album_name correlaciona 0,72 con popularity (más que género, 0,62); se excluyó a propósito</a:t>
             </a:r>
             <a:endParaRPr sz="1500">
               <a:solidFill>
@@ -32340,7 +32340,7 @@
                 <a:cs typeface="Calibri"/>
                 <a:sym typeface="Calibri"/>
               </a:rPr>
-              <a:t>0,71</a:t>
+              <a:t>0,63</a:t>
             </a:r>
             <a:endParaRPr sz="1300">
               <a:solidFill>

</xml_diff>